<commit_message>
Lighten Slide 6: remove dark-navy decision bar and stat tiles
Co-Authored-By: Claude Opus 4.8 <noreply@anthropic.com>
Claude-Session: https://claude.ai/code/session_01K9pCG1KVnQ2TxqkQzmSmDi
</commit_message>
<xml_diff>
--- a/ieom2026_presentation/Slide6_SystemA_redesigned.pptx
+++ b/ieom2026_presentation/Slide6_SystemA_redesigned.pptx
@@ -1500,9 +1500,16 @@
             </a:avLst>
           </a:prstGeom>
           <a:solidFill>
-            <a:schemeClr val="tx2"/>
-          </a:solidFill>
-          <a:ln/>
+            <a:schemeClr val="accent1">
+              <a:alpha val="10000"/>
+            </a:schemeClr>
+          </a:solidFill>
+          <a:ln w="19050">
+            <a:solidFill>
+              <a:schemeClr val="accent1"/>
+            </a:solidFill>
+            <a:prstDash val="solid"/>
+          </a:ln>
         </p:spPr>
       </p:sp>
       <p:sp>
@@ -1520,7 +1527,7 @@
             <a:avLst/>
           </a:prstGeom>
           <a:solidFill>
-            <a:schemeClr val="accent5"/>
+            <a:schemeClr val="accent1"/>
           </a:solidFill>
           <a:ln/>
         </p:spPr>
@@ -1552,7 +1559,7 @@
             <a:r>
               <a:rPr lang="en-US" sz="1800" b="1" dirty="0">
                 <a:solidFill>
-                  <a:schemeClr val="tx2"/>
+                  <a:schemeClr val="bg1"/>
                 </a:solidFill>
               </a:rPr>
               <a:t>?</a:t>
@@ -1588,7 +1595,7 @@
             <a:r>
               <a:rPr lang="en-US" sz="1400" b="1" dirty="0">
                 <a:solidFill>
-                  <a:schemeClr val="bg1"/>
+                  <a:schemeClr val="tx2"/>
                 </a:solidFill>
               </a:rPr>
               <a:t>Check:  right component for this step</a:t>
@@ -1599,7 +1606,7 @@
             <a:r>
               <a:rPr lang="en-US" sz="1400" b="1" dirty="0">
                 <a:solidFill>
-                  <a:schemeClr val="bg1"/>
+                  <a:schemeClr val="tx2"/>
                 </a:solidFill>
               </a:rPr>
               <a:t>  AND  within 0.15 m of its stored pose?</a:t>
@@ -1929,7 +1936,7 @@
             </a:avLst>
           </a:prstGeom>
           <a:solidFill>
-            <a:schemeClr val="tx2"/>
+            <a:schemeClr val="bg2"/>
           </a:solidFill>
           <a:ln/>
         </p:spPr>
@@ -1961,7 +1968,7 @@
             <a:r>
               <a:rPr lang="en-US" sz="2600" b="1" dirty="0">
                 <a:solidFill>
-                  <a:schemeClr val="accent5"/>
+                  <a:schemeClr val="accent1"/>
                 </a:solidFill>
               </a:rPr>
               <a:t>26</a:t>
@@ -2000,7 +2007,7 @@
             <a:r>
               <a:rPr lang="en-US" sz="1150" dirty="0">
                 <a:solidFill>
-                  <a:schemeClr val="bg1"/>
+                  <a:schemeClr val="tx1"/>
                 </a:solidFill>
               </a:rPr>
               <a:t>components</a:t>
@@ -2017,7 +2024,7 @@
             <a:r>
               <a:rPr lang="en-US" sz="1150" dirty="0">
                 <a:solidFill>
-                  <a:schemeClr val="bg1"/>
+                  <a:schemeClr val="tx1"/>
                 </a:solidFill>
               </a:rPr>
               <a:t>(only 2 unique)</a:t>
@@ -2043,7 +2050,7 @@
             </a:avLst>
           </a:prstGeom>
           <a:solidFill>
-            <a:schemeClr val="tx2"/>
+            <a:schemeClr val="bg2"/>
           </a:solidFill>
           <a:ln/>
         </p:spPr>
@@ -2075,7 +2082,7 @@
             <a:r>
               <a:rPr lang="en-US" sz="2600" b="1" dirty="0">
                 <a:solidFill>
-                  <a:schemeClr val="accent5"/>
+                  <a:schemeClr val="accent1"/>
                 </a:solidFill>
               </a:rPr>
               <a:t>52</a:t>
@@ -2114,7 +2121,7 @@
             <a:r>
               <a:rPr lang="en-US" sz="1150" dirty="0">
                 <a:solidFill>
-                  <a:schemeClr val="bg1"/>
+                  <a:schemeClr val="tx1"/>
                 </a:solidFill>
               </a:rPr>
               <a:t>JSON steps</a:t>
@@ -2131,7 +2138,7 @@
             <a:r>
               <a:rPr lang="en-US" sz="1150" dirty="0">
                 <a:solidFill>
-                  <a:schemeClr val="bg1"/>
+                  <a:schemeClr val="tx1"/>
                 </a:solidFill>
               </a:rPr>
               <a:t>(assembly + disassembly)</a:t>
@@ -2157,7 +2164,7 @@
             </a:avLst>
           </a:prstGeom>
           <a:solidFill>
-            <a:schemeClr val="tx2"/>
+            <a:schemeClr val="bg2"/>
           </a:solidFill>
           <a:ln/>
         </p:spPr>
@@ -2189,7 +2196,7 @@
             <a:r>
               <a:rPr lang="en-US" sz="2600" b="1" dirty="0">
                 <a:solidFill>
-                  <a:schemeClr val="accent5"/>
+                  <a:schemeClr val="accent1"/>
                 </a:solidFill>
               </a:rPr>
               <a:t>4</a:t>
@@ -2228,7 +2235,7 @@
             <a:r>
               <a:rPr lang="en-US" sz="1150" dirty="0">
                 <a:solidFill>
-                  <a:schemeClr val="bg1"/>
+                  <a:schemeClr val="tx1"/>
                 </a:solidFill>
               </a:rPr>
               <a:t>action classes</a:t>
@@ -2245,7 +2252,7 @@
             <a:r>
               <a:rPr lang="en-US" sz="1150" dirty="0">
                 <a:solidFill>
-                  <a:schemeClr val="bg1"/>
+                  <a:schemeClr val="tx1"/>
                 </a:solidFill>
               </a:rPr>
               <a:t>place · insert · fasten · remove</a:t>
@@ -2271,7 +2278,7 @@
             </a:avLst>
           </a:prstGeom>
           <a:solidFill>
-            <a:schemeClr val="tx2"/>
+            <a:schemeClr val="bg2"/>
           </a:solidFill>
           <a:ln/>
         </p:spPr>
@@ -2303,7 +2310,7 @@
             <a:r>
               <a:rPr lang="en-US" sz="2600" b="1" dirty="0">
                 <a:solidFill>
-                  <a:schemeClr val="accent5"/>
+                  <a:schemeClr val="accent1"/>
                 </a:solidFill>
               </a:rPr>
               <a:t>2,422</a:t>
@@ -2342,7 +2349,7 @@
             <a:r>
               <a:rPr lang="en-US" sz="1150" dirty="0">
                 <a:solidFill>
-                  <a:schemeClr val="bg1"/>
+                  <a:schemeClr val="tx1"/>
                 </a:solidFill>
               </a:rPr>
               <a:t>lines of code</a:t>
@@ -2359,7 +2366,7 @@
             <a:r>
               <a:rPr lang="en-US" sz="1150" dirty="0">
                 <a:solidFill>
-                  <a:schemeClr val="bg1"/>
+                  <a:schemeClr val="tx1"/>
                 </a:solidFill>
               </a:rPr>
               <a:t>across 10 files</a:t>

</xml_diff>